<commit_message>
Update the exhibition poster: the A3 PowerPoint and the A4 Word version
</commit_message>
<xml_diff>
--- a/docs/poster/SchemeSetu_Poster_A3.pptx
+++ b/docs/poster/SchemeSetu_Poster_A3.pptx
@@ -348,13 +348,6 @@
   <p:clrMapOvr>
     <a:masterClrMapping/>
   </p:clrMapOvr>
-  <p:timing>
-    <p:tnLst>
-      <p:par>
-        <p:cTn id="1" dur="indefinite" restart="never" nodeType="tmRoot"/>
-      </p:par>
-    </p:tnLst>
-  </p:timing>
 </p:sldLayout>
 </file>
 
@@ -460,16 +453,7 @@
                 </a:solidFill>
                 <a:latin typeface="Bahnschrift" panose="020B0502040204020203" pitchFamily="34" charset="0"/>
               </a:rPr>
-              <a:t>PROJECT-I (CEUP 301</a:t>
-            </a:r>
-            <a:r>
-              <a:rPr lang="en-US" sz="1800" b="1" kern="0" spc="200" dirty="0" smtClean="0">
-                <a:solidFill>
-                  <a:schemeClr val="bg1"/>
-                </a:solidFill>
-                <a:latin typeface="Bahnschrift" panose="020B0502040204020203" pitchFamily="34" charset="0"/>
-              </a:rPr>
-              <a:t>)</a:t>
+              <a:t>PROJECT-I (CEUP 301)</a:t>
             </a:r>
             <a:endParaRPr lang="en-US" sz="1800" dirty="0">
               <a:solidFill>
@@ -657,13 +641,6 @@
   <p:clrMapOvr>
     <a:masterClrMapping/>
   </p:clrMapOvr>
-  <p:timing>
-    <p:tnLst>
-      <p:par>
-        <p:cTn id="1" dur="indefinite" restart="never" nodeType="tmRoot"/>
-      </p:par>
-    </p:tnLst>
-  </p:timing>
 </p:sldLayout>
 </file>
 
@@ -975,7 +952,7 @@
         </p:nvSpPr>
         <p:spPr>
           <a:xfrm>
-            <a:off x="7759510" y="2497354"/>
+            <a:off x="7782660" y="2497354"/>
             <a:ext cx="2916936" cy="384048"/>
           </a:xfrm>
           <a:prstGeom prst="rect">
@@ -994,6 +971,13 @@
             <a:softEdge rad="25400"/>
           </a:effectLst>
         </p:spPr>
+        <p:txBody>
+          <a:bodyPr/>
+          <a:lstStyle/>
+          <a:p>
+            <a:endParaRPr lang="en-IN" dirty="0"/>
+          </a:p>
+        </p:txBody>
       </p:sp>
       <p:sp>
         <p:nvSpPr>
@@ -1065,8 +1049,8 @@
         </p:nvSpPr>
         <p:spPr>
           <a:xfrm>
-            <a:off x="365760" y="2951654"/>
-            <a:ext cx="9774936" cy="411480"/>
+            <a:off x="378782" y="3020018"/>
+            <a:ext cx="9944794" cy="411480"/>
           </a:xfrm>
           <a:prstGeom prst="rect">
             <a:avLst/>
@@ -1087,7 +1071,39 @@
                   <a:schemeClr val="tx1"/>
                 </a:solidFill>
               </a:rPr>
-              <a:t>Search 4,722 Indian government schemes and see, in English or Hindi, which ones you are eligible for.</a:t>
+              <a:t>Search 4,722 Indian government schemes and see</a:t>
+            </a:r>
+            <a:r>
+              <a:rPr lang="en-US" sz="1600" b="1" dirty="0">
+                <a:solidFill>
+                  <a:schemeClr val="tx1"/>
+                </a:solidFill>
+              </a:rPr>
+              <a:t> every details</a:t>
+            </a:r>
+            <a:r>
+              <a:rPr lang="en-US" sz="1600" b="1" i="1" dirty="0">
+                <a:solidFill>
+                  <a:schemeClr val="tx1"/>
+                </a:solidFill>
+              </a:rPr>
+              <a:t> in English or Hindi</a:t>
+            </a:r>
+            <a:r>
+              <a:rPr lang="en-US" sz="1600" b="1" dirty="0">
+                <a:solidFill>
+                  <a:schemeClr val="tx1"/>
+                </a:solidFill>
+              </a:rPr>
+              <a:t> and </a:t>
+            </a:r>
+            <a:r>
+              <a:rPr lang="en-US" sz="1600" b="1" i="1" dirty="0">
+                <a:solidFill>
+                  <a:schemeClr val="tx1"/>
+                </a:solidFill>
+              </a:rPr>
+              <a:t>which ones you are eligible for.</a:t>
             </a:r>
           </a:p>
         </p:txBody>
@@ -1101,14 +1117,14 @@
           <p:nvPr>
             <p:extLst>
               <p:ext uri="{D42A27DB-BD31-4B8C-83A1-F6EECF244321}">
-                <p14:modId xmlns:p14="http://schemas.microsoft.com/office/powerpoint/2010/main" val="3531060960"/>
+                <p14:modId xmlns:p14="http://schemas.microsoft.com/office/powerpoint/2010/main" val="3956998490"/>
               </p:ext>
             </p:extLst>
           </p:nvPr>
         </p:nvGraphicFramePr>
         <p:xfrm>
-          <a:off x="374904" y="3522545"/>
-          <a:ext cx="6675120" cy="1097280"/>
+          <a:off x="374904" y="3444181"/>
+          <a:ext cx="6675120" cy="1006998"/>
         </p:xfrm>
         <a:graphic>
           <a:graphicData uri="http://schemas.openxmlformats.org/drawingml/2006/table">
@@ -1137,7 +1153,7 @@
                   </a:extLst>
                 </a:gridCol>
               </a:tblGrid>
-              <a:tr h="365760">
+              <a:tr h="358094">
                 <a:tc>
                   <a:txBody>
                     <a:bodyPr/>
@@ -1327,7 +1343,7 @@
                   </a:ext>
                 </a:extLst>
               </a:tr>
-              <a:tr h="731520">
+              <a:tr h="648904">
                 <a:tc>
                   <a:txBody>
                     <a:bodyPr/>
@@ -1529,8 +1545,8 @@
         </p:nvSpPr>
         <p:spPr>
           <a:xfrm>
-            <a:off x="7232904" y="3522545"/>
-            <a:ext cx="2916936" cy="1097280"/>
+            <a:off x="7232904" y="3425937"/>
+            <a:ext cx="2916936" cy="1025242"/>
           </a:xfrm>
           <a:prstGeom prst="rect">
             <a:avLst/>
@@ -1554,8 +1570,8 @@
         </p:nvSpPr>
         <p:spPr>
           <a:xfrm>
-            <a:off x="7232904" y="3522545"/>
-            <a:ext cx="2916936" cy="384048"/>
+            <a:off x="7232904" y="3431066"/>
+            <a:ext cx="2916936" cy="359580"/>
           </a:xfrm>
           <a:prstGeom prst="rect">
             <a:avLst/>
@@ -1579,7 +1595,7 @@
         </p:nvSpPr>
         <p:spPr>
           <a:xfrm>
-            <a:off x="7370064" y="3522545"/>
+            <a:off x="7356232" y="3408369"/>
             <a:ext cx="2642616" cy="384048"/>
           </a:xfrm>
           <a:prstGeom prst="rect">
@@ -1604,9 +1620,20 @@
                 <a:ea typeface="Arial" pitchFamily="34" charset="-122"/>
                 <a:cs typeface="Arial" pitchFamily="34" charset="-120"/>
               </a:rPr>
-              <a:t>MENTOR / GUIDE</a:t>
-            </a:r>
-            <a:endParaRPr lang="en-US" sz="1800" dirty="0"/>
+              <a:t>MENTOR / </a:t>
+            </a:r>
+            <a:r>
+              <a:rPr lang="en-US" sz="1700" b="1" dirty="0">
+                <a:solidFill>
+                  <a:schemeClr val="bg1"/>
+                </a:solidFill>
+                <a:latin typeface="Arial" pitchFamily="34" charset="0"/>
+                <a:ea typeface="Arial" pitchFamily="34" charset="-122"/>
+                <a:cs typeface="Arial" pitchFamily="34" charset="-120"/>
+              </a:rPr>
+              <a:t>GUIDE</a:t>
+            </a:r>
+            <a:endParaRPr lang="en-US" sz="1700" dirty="0"/>
           </a:p>
         </p:txBody>
       </p:sp>
@@ -1618,8 +1645,8 @@
         </p:nvSpPr>
         <p:spPr>
           <a:xfrm>
-            <a:off x="7339584" y="3949844"/>
-            <a:ext cx="2651760" cy="868680"/>
+            <a:off x="7315200" y="3844539"/>
+            <a:ext cx="2651760" cy="525838"/>
           </a:xfrm>
           <a:prstGeom prst="rect">
             <a:avLst/>
@@ -1674,7 +1701,7 @@
         </p:nvSpPr>
         <p:spPr>
           <a:xfrm>
-            <a:off x="374904" y="5019141"/>
+            <a:off x="374904" y="4617804"/>
             <a:ext cx="9774936" cy="2606040"/>
           </a:xfrm>
           <a:prstGeom prst="rect">
@@ -1699,7 +1726,7 @@
         </p:nvSpPr>
         <p:spPr>
           <a:xfrm>
-            <a:off x="374904" y="5019141"/>
+            <a:off x="374904" y="4617804"/>
             <a:ext cx="9774936" cy="411480"/>
           </a:xfrm>
           <a:prstGeom prst="rect">
@@ -1724,7 +1751,7 @@
         </p:nvSpPr>
         <p:spPr>
           <a:xfrm>
-            <a:off x="512064" y="5019141"/>
+            <a:off x="512064" y="4617804"/>
             <a:ext cx="9500616" cy="411480"/>
           </a:xfrm>
           <a:prstGeom prst="rect">
@@ -1776,8 +1803,8 @@
         </p:nvSpPr>
         <p:spPr>
           <a:xfrm>
-            <a:off x="644652" y="5750661"/>
-            <a:ext cx="1554480" cy="1143000"/>
+            <a:off x="639731" y="5334618"/>
+            <a:ext cx="1554480" cy="1354910"/>
           </a:xfrm>
           <a:prstGeom prst="roundRect">
             <a:avLst>
@@ -1785,9 +1812,7 @@
             </a:avLst>
           </a:prstGeom>
           <a:solidFill>
-            <a:schemeClr val="accent5">
-              <a:lumMod val="75000"/>
-            </a:schemeClr>
+            <a:schemeClr val="bg1"/>
           </a:solidFill>
           <a:ln w="6350">
             <a:solidFill>
@@ -1805,7 +1830,7 @@
         </p:nvSpPr>
         <p:spPr>
           <a:xfrm>
-            <a:off x="699516" y="5805525"/>
+            <a:off x="699516" y="5473638"/>
             <a:ext cx="1444752" cy="1033272"/>
           </a:xfrm>
           <a:prstGeom prst="rect">
@@ -1822,11 +1847,7 @@
               <a:buNone/>
             </a:pPr>
             <a:r>
-              <a:rPr lang="en-US" sz="1500" b="1" dirty="0">
-                <a:solidFill>
-                  <a:schemeClr val="bg1"/>
-                </a:solidFill>
-              </a:rPr>
+              <a:rPr lang="en-US" sz="1500" b="1" dirty="0"/>
               <a:t>User</a:t>
             </a:r>
           </a:p>
@@ -1835,12 +1856,16 @@
               <a:buNone/>
             </a:pPr>
             <a:r>
-              <a:rPr lang="en-US" sz="1100" b="0" dirty="0">
-                <a:solidFill>
-                  <a:schemeClr val="bg1"/>
-                </a:solidFill>
-              </a:rPr>
-              <a:t>React web app (English, हिन्दी)</a:t>
+              <a:rPr lang="en-US" sz="1100" b="0" dirty="0"/>
+              <a:t>React web app (English, </a:t>
+            </a:r>
+            <a:r>
+              <a:rPr lang="en-US" sz="1000" b="0" dirty="0"/>
+              <a:t>हिन्दी</a:t>
+            </a:r>
+            <a:r>
+              <a:rPr lang="en-US" sz="1100" b="0" dirty="0"/>
+              <a:t>)</a:t>
             </a:r>
           </a:p>
         </p:txBody>
@@ -1853,7 +1878,7 @@
         </p:nvSpPr>
         <p:spPr>
           <a:xfrm>
-            <a:off x="2253996" y="6185001"/>
+            <a:off x="2253996" y="5853114"/>
             <a:ext cx="256032" cy="274320"/>
           </a:xfrm>
           <a:prstGeom prst="rightArrow">
@@ -1878,8 +1903,8 @@
         </p:nvSpPr>
         <p:spPr>
           <a:xfrm>
-            <a:off x="2564892" y="5750661"/>
-            <a:ext cx="1554480" cy="1143000"/>
+            <a:off x="2564892" y="5325326"/>
+            <a:ext cx="1554480" cy="1354910"/>
           </a:xfrm>
           <a:prstGeom prst="roundRect">
             <a:avLst>
@@ -1887,7 +1912,7 @@
             </a:avLst>
           </a:prstGeom>
           <a:solidFill>
-            <a:srgbClr val="1960A3"/>
+            <a:schemeClr val="bg1"/>
           </a:solidFill>
           <a:ln w="6350">
             <a:solidFill>
@@ -1905,7 +1930,7 @@
         </p:nvSpPr>
         <p:spPr>
           <a:xfrm>
-            <a:off x="2619756" y="5805525"/>
+            <a:off x="2619756" y="5473638"/>
             <a:ext cx="1444752" cy="1033272"/>
           </a:xfrm>
           <a:prstGeom prst="rect">
@@ -1928,13 +1953,21 @@
           </a:lstStyle>
           <a:p>
             <a:r>
-              <a:rPr lang="en-US" dirty="0" sz="1500" b="1"/>
+              <a:rPr lang="en-US" sz="1500" b="1" dirty="0">
+                <a:solidFill>
+                  <a:schemeClr val="tx1"/>
+                </a:solidFill>
+              </a:rPr>
               <a:t>Express API</a:t>
             </a:r>
           </a:p>
           <a:p>
             <a:r>
-              <a:rPr lang="en-US" dirty="0" sz="1100" b="0"/>
+              <a:rPr lang="en-US" sz="1100" b="0" dirty="0">
+                <a:solidFill>
+                  <a:schemeClr val="tx1"/>
+                </a:solidFill>
+              </a:rPr>
               <a:t>Google sign-in, validation, rate limits</a:t>
             </a:r>
           </a:p>
@@ -1948,7 +1981,7 @@
         </p:nvSpPr>
         <p:spPr>
           <a:xfrm>
-            <a:off x="4174236" y="6185001"/>
+            <a:off x="4174236" y="5853114"/>
             <a:ext cx="256032" cy="274320"/>
           </a:xfrm>
           <a:prstGeom prst="rightArrow">
@@ -1973,8 +2006,8 @@
         </p:nvSpPr>
         <p:spPr>
           <a:xfrm>
-            <a:off x="4485132" y="5750661"/>
-            <a:ext cx="1554480" cy="1143000"/>
+            <a:off x="4456918" y="5334618"/>
+            <a:ext cx="1554480" cy="1354910"/>
           </a:xfrm>
           <a:prstGeom prst="roundRect">
             <a:avLst>
@@ -1982,9 +2015,7 @@
             </a:avLst>
           </a:prstGeom>
           <a:solidFill>
-            <a:schemeClr val="accent5">
-              <a:lumMod val="75000"/>
-            </a:schemeClr>
+            <a:schemeClr val="bg2"/>
           </a:solidFill>
           <a:ln w="6350">
             <a:solidFill>
@@ -2002,7 +2033,7 @@
         </p:nvSpPr>
         <p:spPr>
           <a:xfrm>
-            <a:off x="4539996" y="5805525"/>
+            <a:off x="4539996" y="5473638"/>
             <a:ext cx="1444752" cy="1033272"/>
           </a:xfrm>
           <a:prstGeom prst="rect">
@@ -2019,11 +2050,7 @@
               <a:buNone/>
             </a:pPr>
             <a:r>
-              <a:rPr lang="en-US" sz="1500" b="1" dirty="0">
-                <a:solidFill>
-                  <a:schemeClr val="bg1"/>
-                </a:solidFill>
-              </a:rPr>
+              <a:rPr lang="en-US" sz="1500" b="1" dirty="0"/>
               <a:t>Eligibility Engine</a:t>
             </a:r>
           </a:p>
@@ -2032,11 +2059,7 @@
               <a:buNone/>
             </a:pPr>
             <a:r>
-              <a:rPr lang="en-US" sz="1100" b="0" dirty="0">
-                <a:solidFill>
-                  <a:schemeClr val="bg1"/>
-                </a:solidFill>
-              </a:rPr>
+              <a:rPr lang="en-US" sz="1100" b="0" dirty="0"/>
               <a:t>Rule checks; unknown never excludes</a:t>
             </a:r>
           </a:p>
@@ -2050,7 +2073,7 @@
         </p:nvSpPr>
         <p:spPr>
           <a:xfrm>
-            <a:off x="6094476" y="6185001"/>
+            <a:off x="6094476" y="5853114"/>
             <a:ext cx="256032" cy="274320"/>
           </a:xfrm>
           <a:prstGeom prst="rightArrow">
@@ -2075,8 +2098,8 @@
         </p:nvSpPr>
         <p:spPr>
           <a:xfrm>
-            <a:off x="6405372" y="5750661"/>
-            <a:ext cx="1554480" cy="1143000"/>
+            <a:off x="6405372" y="5334618"/>
+            <a:ext cx="1554480" cy="1354910"/>
           </a:xfrm>
           <a:prstGeom prst="roundRect">
             <a:avLst>
@@ -2084,7 +2107,7 @@
             </a:avLst>
           </a:prstGeom>
           <a:solidFill>
-            <a:srgbClr val="1960A3"/>
+            <a:schemeClr val="bg1"/>
           </a:solidFill>
           <a:ln w="6350">
             <a:solidFill>
@@ -2102,7 +2125,7 @@
         </p:nvSpPr>
         <p:spPr>
           <a:xfrm>
-            <a:off x="6460236" y="5805525"/>
+            <a:off x="6460236" y="5473638"/>
             <a:ext cx="1444752" cy="1033272"/>
           </a:xfrm>
           <a:prstGeom prst="rect">
@@ -2119,11 +2142,7 @@
               <a:buNone/>
             </a:pPr>
             <a:r>
-              <a:rPr lang="en-US" sz="1500" b="1" dirty="0" smtClean="0">
-                <a:solidFill>
-                  <a:schemeClr val="bg1"/>
-                </a:solidFill>
-              </a:rPr>
+              <a:rPr lang="en-US" sz="1500" b="1" dirty="0"/>
               <a:t>PostgreSQL</a:t>
             </a:r>
           </a:p>
@@ -2132,11 +2151,7 @@
               <a:buNone/>
             </a:pPr>
             <a:r>
-              <a:rPr lang="en-US" sz="1100" b="0" dirty="0" smtClean="0">
-                <a:solidFill>
-                  <a:schemeClr val="bg1"/>
-                </a:solidFill>
-              </a:rPr>
+              <a:rPr lang="en-US" sz="1100" b="0" dirty="0"/>
               <a:t>4,722 schemes, 2,987 rule sets (Prisma)</a:t>
             </a:r>
           </a:p>
@@ -2150,7 +2165,7 @@
         </p:nvSpPr>
         <p:spPr>
           <a:xfrm>
-            <a:off x="8014716" y="6185001"/>
+            <a:off x="8014716" y="5853114"/>
             <a:ext cx="256032" cy="274320"/>
           </a:xfrm>
           <a:prstGeom prst="rightArrow">
@@ -2175,8 +2190,8 @@
         </p:nvSpPr>
         <p:spPr>
           <a:xfrm>
-            <a:off x="8325612" y="5750661"/>
-            <a:ext cx="1554480" cy="1143000"/>
+            <a:off x="8325612" y="5370289"/>
+            <a:ext cx="1554480" cy="1354910"/>
           </a:xfrm>
           <a:prstGeom prst="roundRect">
             <a:avLst>
@@ -2184,9 +2199,7 @@
             </a:avLst>
           </a:prstGeom>
           <a:solidFill>
-            <a:schemeClr val="accent5">
-              <a:lumMod val="75000"/>
-            </a:schemeClr>
+            <a:schemeClr val="bg2"/>
           </a:solidFill>
           <a:ln w="6350">
             <a:solidFill>
@@ -2195,6 +2208,13 @@
             <a:prstDash val="solid"/>
           </a:ln>
         </p:spPr>
+        <p:txBody>
+          <a:bodyPr/>
+          <a:lstStyle/>
+          <a:p>
+            <a:endParaRPr lang="en-IN" dirty="0"/>
+          </a:p>
+        </p:txBody>
       </p:sp>
       <p:sp>
         <p:nvSpPr>
@@ -2204,7 +2224,7 @@
         </p:nvSpPr>
         <p:spPr>
           <a:xfrm>
-            <a:off x="8380476" y="5805525"/>
+            <a:off x="8380476" y="5473638"/>
             <a:ext cx="1444752" cy="1033272"/>
           </a:xfrm>
           <a:prstGeom prst="rect">
@@ -2221,11 +2241,7 @@
               <a:buNone/>
             </a:pPr>
             <a:r>
-              <a:rPr lang="en-US" sz="1500" b="1" dirty="0">
-                <a:solidFill>
-                  <a:schemeClr val="bg1"/>
-                </a:solidFill>
-              </a:rPr>
+              <a:rPr lang="en-US" sz="1500" b="1" dirty="0"/>
               <a:t>Ranked Results</a:t>
             </a:r>
           </a:p>
@@ -2234,11 +2250,7 @@
               <a:buNone/>
             </a:pPr>
             <a:r>
-              <a:rPr lang="en-US" sz="1100" b="0" dirty="0">
-                <a:solidFill>
-                  <a:schemeClr val="bg1"/>
-                </a:solidFill>
-              </a:rPr>
+              <a:rPr lang="en-US" sz="1100" b="0" dirty="0"/>
               <a:t>Match %, 100% matches first</a:t>
             </a:r>
           </a:p>
@@ -2252,8 +2264,8 @@
         </p:nvSpPr>
         <p:spPr>
           <a:xfrm>
-            <a:off x="557784" y="7122261"/>
-            <a:ext cx="9409176" cy="774136"/>
+            <a:off x="639731" y="6943488"/>
+            <a:ext cx="9409176" cy="293584"/>
           </a:xfrm>
           <a:prstGeom prst="rect">
             <a:avLst/>
@@ -2273,15 +2285,6 @@
               <a:t>Data pipeline: myScheme.gov.in dataset → parser (cleans text, extracts eligibility rules) → PostgreSQL.</a:t>
             </a:r>
           </a:p>
-          <a:p>
-            <a:pPr marL="0" indent="0">
-              <a:buNone/>
-            </a:pPr>
-            <a:r>
-              <a:rPr lang="en-US" sz="1400" b="1" i="1" dirty="0"/>
-              <a:t>Hindi text is made once by an AI model (Groq) with automatic quality checks, then stored.</a:t>
-            </a:r>
-          </a:p>
         </p:txBody>
       </p:sp>
       <p:sp>
@@ -2292,8 +2295,8 @@
         </p:nvSpPr>
         <p:spPr>
           <a:xfrm>
-            <a:off x="374904" y="7739481"/>
-            <a:ext cx="3136392" cy="2240280"/>
+            <a:off x="374904" y="7442133"/>
+            <a:ext cx="3136392" cy="2161840"/>
           </a:xfrm>
           <a:prstGeom prst="rect">
             <a:avLst/>
@@ -2317,8 +2320,8 @@
         </p:nvSpPr>
         <p:spPr>
           <a:xfrm>
-            <a:off x="374904" y="7739481"/>
-            <a:ext cx="3136392" cy="365760"/>
+            <a:off x="374904" y="7442133"/>
+            <a:ext cx="3136392" cy="352954"/>
           </a:xfrm>
           <a:prstGeom prst="rect">
             <a:avLst/>
@@ -2342,8 +2345,8 @@
         </p:nvSpPr>
         <p:spPr>
           <a:xfrm>
-            <a:off x="512064" y="7739481"/>
-            <a:ext cx="2862072" cy="365760"/>
+            <a:off x="512064" y="7442133"/>
+            <a:ext cx="2862072" cy="352954"/>
           </a:xfrm>
           <a:prstGeom prst="rect">
             <a:avLst/>
@@ -2392,8 +2395,8 @@
         </p:nvSpPr>
         <p:spPr>
           <a:xfrm>
-            <a:off x="512064" y="8196681"/>
-            <a:ext cx="2862072" cy="1737360"/>
+            <a:off x="512064" y="7899332"/>
+            <a:ext cx="2862072" cy="1676529"/>
           </a:xfrm>
           <a:prstGeom prst="rect">
             <a:avLst/>
@@ -2410,7 +2413,7 @@
               <a:buChar char="•"/>
             </a:pPr>
             <a:r>
-              <a:rPr lang="en-US" sz="1300" dirty="0">
+              <a:rPr lang="en-US" sz="1400" dirty="0">
                 <a:solidFill>
                   <a:schemeClr val="tx1"/>
                 </a:solidFill>
@@ -2424,7 +2427,7 @@
               <a:buChar char="•"/>
             </a:pPr>
             <a:r>
-              <a:rPr lang="en-US" sz="1300" dirty="0">
+              <a:rPr lang="en-US" sz="1400" dirty="0">
                 <a:solidFill>
                   <a:schemeClr val="tx1"/>
                 </a:solidFill>
@@ -2438,12 +2441,12 @@
               <a:buChar char="•"/>
             </a:pPr>
             <a:r>
-              <a:rPr lang="en-US" sz="1300" dirty="0">
+              <a:rPr lang="en-US" sz="1400" dirty="0">
                 <a:solidFill>
                   <a:schemeClr val="tx1"/>
                 </a:solidFill>
               </a:rPr>
-              <a:t>Tools: Google OAuth, Zod, Groq AI (Hindi), Vitest (1,035 tests), GitHub Actions CI</a:t>
+              <a:t>Tools: Google OAuth, Groq AI (Hindi/chat), Vitest (1,035 tests), GitHub Actions CI</a:t>
             </a:r>
           </a:p>
         </p:txBody>
@@ -2456,8 +2459,8 @@
         </p:nvSpPr>
         <p:spPr>
           <a:xfrm>
-            <a:off x="3694176" y="7739481"/>
-            <a:ext cx="3136392" cy="2240280"/>
+            <a:off x="3694176" y="7442133"/>
+            <a:ext cx="3136392" cy="2161840"/>
           </a:xfrm>
           <a:prstGeom prst="rect">
             <a:avLst/>
@@ -2481,8 +2484,8 @@
         </p:nvSpPr>
         <p:spPr>
           <a:xfrm>
-            <a:off x="3694176" y="7739481"/>
-            <a:ext cx="3136392" cy="365760"/>
+            <a:off x="3694176" y="7442133"/>
+            <a:ext cx="3136392" cy="352954"/>
           </a:xfrm>
           <a:prstGeom prst="rect">
             <a:avLst/>
@@ -2506,8 +2509,8 @@
         </p:nvSpPr>
         <p:spPr>
           <a:xfrm>
-            <a:off x="3831336" y="7739481"/>
-            <a:ext cx="2862072" cy="365760"/>
+            <a:off x="3831336" y="7442133"/>
+            <a:ext cx="2862072" cy="352954"/>
           </a:xfrm>
           <a:prstGeom prst="rect">
             <a:avLst/>
@@ -2558,8 +2561,8 @@
         </p:nvSpPr>
         <p:spPr>
           <a:xfrm>
-            <a:off x="3831336" y="8196681"/>
-            <a:ext cx="2862072" cy="1737360"/>
+            <a:off x="3831336" y="7899332"/>
+            <a:ext cx="2862072" cy="1676529"/>
           </a:xfrm>
           <a:prstGeom prst="rect">
             <a:avLst/>
@@ -2576,12 +2579,12 @@
               <a:buChar char="•"/>
             </a:pPr>
             <a:r>
-              <a:rPr lang="en-US" sz="1300" dirty="0">
+              <a:rPr lang="en-US" sz="1400" dirty="0">
                 <a:solidFill>
                   <a:schemeClr val="tx1"/>
                 </a:solidFill>
               </a:rPr>
-              <a:t>Eligibility check with match % and reasons, 100% matches first</a:t>
+              <a:t>Eligibility check with match % and reasons</a:t>
             </a:r>
           </a:p>
           <a:p>
@@ -2590,7 +2593,7 @@
               <a:buChar char="•"/>
             </a:pPr>
             <a:r>
-              <a:rPr lang="en-US" sz="1300" dirty="0">
+              <a:rPr lang="en-US" sz="1400" dirty="0">
                 <a:solidFill>
                   <a:schemeClr val="tx1"/>
                 </a:solidFill>
@@ -2604,12 +2607,20 @@
               <a:buChar char="•"/>
             </a:pPr>
             <a:r>
-              <a:rPr lang="en-US" sz="1300" dirty="0">
+              <a:rPr lang="en-US" sz="1400" dirty="0" err="1">
                 <a:solidFill>
                   <a:schemeClr val="tx1"/>
                 </a:solidFill>
               </a:rPr>
-              <a:t>English and Hindi (Hindi labelled as machine-translated)</a:t>
+              <a:t>SetuAI</a:t>
+            </a:r>
+            <a:r>
+              <a:rPr lang="en-US" sz="1400" dirty="0">
+                <a:solidFill>
+                  <a:schemeClr val="tx1"/>
+                </a:solidFill>
+              </a:rPr>
+              <a:t> Assistant</a:t>
             </a:r>
           </a:p>
           <a:p>
@@ -2618,7 +2629,7 @@
               <a:buChar char="•"/>
             </a:pPr>
             <a:r>
-              <a:rPr lang="en-US" sz="1300" dirty="0">
+              <a:rPr lang="en-US" sz="1400" dirty="0">
                 <a:solidFill>
                   <a:schemeClr val="tx1"/>
                 </a:solidFill>
@@ -2636,8 +2647,8 @@
         </p:nvSpPr>
         <p:spPr>
           <a:xfrm>
-            <a:off x="7013448" y="7739481"/>
-            <a:ext cx="3136392" cy="2240280"/>
+            <a:off x="7013448" y="7442133"/>
+            <a:ext cx="3136392" cy="2161840"/>
           </a:xfrm>
           <a:prstGeom prst="rect">
             <a:avLst/>
@@ -2661,8 +2672,8 @@
         </p:nvSpPr>
         <p:spPr>
           <a:xfrm>
-            <a:off x="7013448" y="7739481"/>
-            <a:ext cx="3136392" cy="365760"/>
+            <a:off x="7013448" y="7442133"/>
+            <a:ext cx="3136392" cy="352954"/>
           </a:xfrm>
           <a:prstGeom prst="rect">
             <a:avLst/>
@@ -2686,8 +2697,8 @@
         </p:nvSpPr>
         <p:spPr>
           <a:xfrm>
-            <a:off x="7150608" y="7739481"/>
-            <a:ext cx="2862072" cy="365760"/>
+            <a:off x="7150608" y="7442133"/>
+            <a:ext cx="2862072" cy="352954"/>
           </a:xfrm>
           <a:prstGeom prst="rect">
             <a:avLst/>
@@ -2727,8 +2738,8 @@
         </p:nvSpPr>
         <p:spPr>
           <a:xfrm>
-            <a:off x="7150608" y="8196681"/>
-            <a:ext cx="2862072" cy="1737360"/>
+            <a:off x="7150608" y="7899332"/>
+            <a:ext cx="2862072" cy="1676529"/>
           </a:xfrm>
           <a:prstGeom prst="rect">
             <a:avLst/>
@@ -2745,7 +2756,7 @@
               <a:buChar char="•"/>
             </a:pPr>
             <a:r>
-              <a:rPr lang="en-US" sz="1300" dirty="0">
+              <a:rPr lang="en-US" sz="1400" dirty="0">
                 <a:solidFill>
                   <a:schemeClr val="tx1"/>
                 </a:solidFill>
@@ -2759,7 +2770,7 @@
               <a:buChar char="•"/>
             </a:pPr>
             <a:r>
-              <a:rPr lang="en-US" sz="1300" dirty="0">
+              <a:rPr lang="en-US" sz="1400" dirty="0">
                 <a:solidFill>
                   <a:schemeClr val="tx1"/>
                 </a:solidFill>
@@ -2773,7 +2784,7 @@
               <a:buChar char="•"/>
             </a:pPr>
             <a:r>
-              <a:rPr lang="en-US" sz="1300" dirty="0">
+              <a:rPr lang="en-US" sz="1400" dirty="0">
                 <a:solidFill>
                   <a:schemeClr val="tx1"/>
                 </a:solidFill>
@@ -2791,8 +2802,8 @@
         </p:nvSpPr>
         <p:spPr>
           <a:xfrm>
-            <a:off x="374904" y="10094061"/>
-            <a:ext cx="9774936" cy="3703320"/>
+            <a:off x="374904" y="9801123"/>
+            <a:ext cx="9774936" cy="3948146"/>
           </a:xfrm>
           <a:prstGeom prst="rect">
             <a:avLst/>
@@ -2816,8 +2827,8 @@
         </p:nvSpPr>
         <p:spPr>
           <a:xfrm>
-            <a:off x="374904" y="10094061"/>
-            <a:ext cx="9774936" cy="514350"/>
+            <a:off x="374904" y="9801123"/>
+            <a:ext cx="9774936" cy="548354"/>
           </a:xfrm>
           <a:prstGeom prst="rect">
             <a:avLst/>
@@ -2841,8 +2852,8 @@
         </p:nvSpPr>
         <p:spPr>
           <a:xfrm>
-            <a:off x="512064" y="10094061"/>
-            <a:ext cx="9500616" cy="514350"/>
+            <a:off x="512064" y="9801123"/>
+            <a:ext cx="9500616" cy="548354"/>
           </a:xfrm>
           <a:prstGeom prst="rect">
             <a:avLst/>
@@ -2893,8 +2904,8 @@
         </p:nvSpPr>
         <p:spPr>
           <a:xfrm>
-            <a:off x="570675" y="10847665"/>
-            <a:ext cx="3014472" cy="2788920"/>
+            <a:off x="570675" y="10554727"/>
+            <a:ext cx="3014472" cy="2973296"/>
           </a:xfrm>
           <a:prstGeom prst="rect">
             <a:avLst/>
@@ -2918,8 +2929,8 @@
         </p:nvSpPr>
         <p:spPr>
           <a:xfrm>
-            <a:off x="570675" y="13109056"/>
-            <a:ext cx="3014472" cy="457200"/>
+            <a:off x="570675" y="13139441"/>
+            <a:ext cx="3014472" cy="487425"/>
           </a:xfrm>
           <a:prstGeom prst="rect">
             <a:avLst/>
@@ -2940,7 +2951,7 @@
                   <a:schemeClr val="tx2"/>
                 </a:solidFill>
               </a:rPr>
-              <a:t>Home – search 4,722 schemes</a:t>
+              <a:t>Home - search 4,722 schemes</a:t>
             </a:r>
           </a:p>
         </p:txBody>
@@ -2953,8 +2964,8 @@
         </p:nvSpPr>
         <p:spPr>
           <a:xfrm>
-            <a:off x="3768027" y="10847665"/>
-            <a:ext cx="3014472" cy="2788920"/>
+            <a:off x="3768027" y="10554727"/>
+            <a:ext cx="3014472" cy="2973296"/>
           </a:xfrm>
           <a:prstGeom prst="rect">
             <a:avLst/>
@@ -2978,8 +2989,8 @@
         </p:nvSpPr>
         <p:spPr>
           <a:xfrm>
-            <a:off x="3768027" y="13108519"/>
-            <a:ext cx="3014472" cy="457200"/>
+            <a:off x="3768027" y="13138904"/>
+            <a:ext cx="3014472" cy="487425"/>
           </a:xfrm>
           <a:prstGeom prst="rect">
             <a:avLst/>
@@ -3000,7 +3011,7 @@
                   <a:schemeClr val="tx2"/>
                 </a:solidFill>
               </a:rPr>
-              <a:t>Eligibility check – 100% matches first</a:t>
+              <a:t>User Dashboard </a:t>
             </a:r>
           </a:p>
         </p:txBody>
@@ -3013,8 +3024,8 @@
         </p:nvSpPr>
         <p:spPr>
           <a:xfrm>
-            <a:off x="6965379" y="10847665"/>
-            <a:ext cx="3014472" cy="2788920"/>
+            <a:off x="6965379" y="10554727"/>
+            <a:ext cx="3014472" cy="2973296"/>
           </a:xfrm>
           <a:prstGeom prst="rect">
             <a:avLst/>
@@ -3038,8 +3049,8 @@
         </p:nvSpPr>
         <p:spPr>
           <a:xfrm>
-            <a:off x="6965379" y="13108519"/>
-            <a:ext cx="3014472" cy="457200"/>
+            <a:off x="6965378" y="13138904"/>
+            <a:ext cx="3001581" cy="487425"/>
           </a:xfrm>
           <a:prstGeom prst="rect">
             <a:avLst/>
@@ -3051,16 +3062,14 @@
           <a:bodyPr wrap="square" lIns="0" tIns="0" rIns="0" bIns="0" rtlCol="0" anchor="ctr"/>
           <a:lstStyle/>
           <a:p>
-            <a:pPr marL="0" indent="0" algn="ctr">
-              <a:buNone/>
-            </a:pPr>
+            <a:pPr algn="ctr"/>
             <a:r>
               <a:rPr lang="en-US" sz="1300" b="1" dirty="0">
                 <a:solidFill>
                   <a:schemeClr val="tx2"/>
                 </a:solidFill>
               </a:rPr>
-              <a:t>Hindi interface (हिन्दी)</a:t>
+              <a:t>User Dashboard Hindi interface</a:t>
             </a:r>
           </a:p>
         </p:txBody>
@@ -3073,8 +3082,8 @@
         </p:nvSpPr>
         <p:spPr>
           <a:xfrm>
-            <a:off x="7850950" y="2497477"/>
-            <a:ext cx="2642616" cy="384048"/>
+            <a:off x="8142732" y="2507540"/>
+            <a:ext cx="2286058" cy="384048"/>
           </a:xfrm>
           <a:prstGeom prst="rect">
             <a:avLst/>
@@ -3090,7 +3099,7 @@
               <a:buNone/>
             </a:pPr>
             <a:r>
-              <a:rPr lang="en-US" sz="1800" b="1" dirty="0" smtClean="0">
+              <a:rPr lang="en-US" sz="1800" b="1" dirty="0">
                 <a:solidFill>
                   <a:schemeClr val="bg1"/>
                 </a:solidFill>
@@ -3098,7 +3107,7 @@
                 <a:ea typeface="Arial" pitchFamily="34" charset="-122"/>
                 <a:cs typeface="Arial" pitchFamily="34" charset="-120"/>
               </a:rPr>
-              <a:t>Group Id- CS26015</a:t>
+              <a:t>Group Id - CS26015</a:t>
             </a:r>
           </a:p>
         </p:txBody>
@@ -3111,14 +3120,14 @@
         </p:nvSpPr>
         <p:spPr>
           <a:xfrm>
-            <a:off x="374904" y="13911681"/>
-            <a:ext cx="9774936" cy="514350"/>
-          </a:xfrm>
-          <a:prstGeom prst="rect">
-            <a:avLst/>
-          </a:prstGeom>
-          <a:solidFill>
-            <a:srgbClr val="1960A3"/>
+            <a:off x="332852" y="13946419"/>
+            <a:ext cx="9802612" cy="514350"/>
+          </a:xfrm>
+          <a:prstGeom prst="rect">
+            <a:avLst/>
+          </a:prstGeom>
+          <a:solidFill>
+            <a:schemeClr val="bg2"/>
           </a:solidFill>
           <a:ln w="6350">
             <a:solidFill>
@@ -3136,7 +3145,7 @@
         </p:nvSpPr>
         <p:spPr>
           <a:xfrm>
-            <a:off x="512064" y="13911681"/>
+            <a:off x="550863" y="13980957"/>
             <a:ext cx="9500616" cy="514350"/>
           </a:xfrm>
           <a:prstGeom prst="rect">
@@ -3149,11 +3158,9 @@
           <a:bodyPr wrap="square" lIns="0" tIns="0" rIns="0" bIns="0" rtlCol="0" anchor="ctr"/>
           <a:lstStyle/>
           <a:p>
-            <a:r>
-              <a:rPr lang="en-US" b="1" dirty="0" sz="2000">
-                <a:solidFill>
-                  <a:schemeClr val="bg1"/>
-                </a:solidFill>
+            <a:pPr algn="ctr"/>
+            <a:r>
+              <a:rPr lang="en-US" b="1" dirty="0">
                 <a:latin typeface="Arial" pitchFamily="34" charset="0"/>
                 <a:ea typeface="Arial" pitchFamily="34" charset="-122"/>
                 <a:cs typeface="Arial" pitchFamily="34" charset="-120"/>
@@ -3173,14 +3180,15 @@
         </p:nvPicPr>
         <p:blipFill>
           <a:blip r:embed="rId3"/>
+          <a:srcRect l="5743" t="5443" r="4807" b="15251"/>
           <a:stretch>
             <a:fillRect/>
           </a:stretch>
         </p:blipFill>
         <p:spPr>
           <a:xfrm>
-            <a:off x="643827" y="10920817"/>
-            <a:ext cx="2868168" cy="2151663"/>
+            <a:off x="639731" y="10613926"/>
+            <a:ext cx="2871565" cy="2461669"/>
           </a:xfrm>
           <a:prstGeom prst="rect">
             <a:avLst/>
@@ -3189,7 +3197,13 @@
       </p:pic>
       <p:pic>
         <p:nvPicPr>
-          <p:cNvPr id="65" name="Screenshot 2" descr="image.png"/>
+          <p:cNvPr id="11" name="Picture 10">
+            <a:extLst>
+              <a:ext uri="{FF2B5EF4-FFF2-40B4-BE49-F238E27FC236}">
+                <a16:creationId xmlns:a16="http://schemas.microsoft.com/office/drawing/2014/main" id="{732A3B2C-138A-9826-E57A-35B480433D44}"/>
+              </a:ext>
+            </a:extLst>
+          </p:cNvPr>
           <p:cNvPicPr>
             <a:picLocks noChangeAspect="1"/>
           </p:cNvPicPr>
@@ -3197,14 +3211,15 @@
         </p:nvPicPr>
         <p:blipFill>
           <a:blip r:embed="rId4"/>
+          <a:srcRect r="9720"/>
           <a:stretch>
             <a:fillRect/>
           </a:stretch>
         </p:blipFill>
         <p:spPr>
           <a:xfrm>
-            <a:off x="3841179" y="10920817"/>
-            <a:ext cx="2868168" cy="2151126"/>
+            <a:off x="3819538" y="10627880"/>
+            <a:ext cx="2911449" cy="2511561"/>
           </a:xfrm>
           <a:prstGeom prst="rect">
             <a:avLst/>
@@ -3213,7 +3228,13 @@
       </p:pic>
       <p:pic>
         <p:nvPicPr>
-          <p:cNvPr id="66" name="Screenshot 3" descr="image.png"/>
+          <p:cNvPr id="14" name="Picture 13">
+            <a:extLst>
+              <a:ext uri="{FF2B5EF4-FFF2-40B4-BE49-F238E27FC236}">
+                <a16:creationId xmlns:a16="http://schemas.microsoft.com/office/drawing/2014/main" id="{D76E2E32-B898-905E-EF7F-73733277E1B5}"/>
+              </a:ext>
+            </a:extLst>
+          </p:cNvPr>
           <p:cNvPicPr>
             <a:picLocks noChangeAspect="1"/>
           </p:cNvPicPr>
@@ -3227,8 +3248,8 @@
         </p:blipFill>
         <p:spPr>
           <a:xfrm>
-            <a:off x="7038531" y="10920817"/>
-            <a:ext cx="2868168" cy="2151126"/>
+            <a:off x="7032102" y="10627879"/>
+            <a:ext cx="2847990" cy="2511562"/>
           </a:xfrm>
           <a:prstGeom prst="rect">
             <a:avLst/>
@@ -3240,13 +3261,6 @@
   <p:clrMapOvr>
     <a:masterClrMapping/>
   </p:clrMapOvr>
-  <p:timing>
-    <p:tnLst>
-      <p:par>
-        <p:cTn id="1" dur="indefinite" restart="never" nodeType="tmRoot"/>
-      </p:par>
-    </p:tnLst>
-  </p:timing>
 </p:sld>
 </file>
 

</xml_diff>